<commit_message>
Inclui as falas do roteiro de gravação nas anotações dos slides das Unidades 1 a 4 de Estado, Governo e Mercado
Co-Authored-By: Claude Opus 5.5 <noreply@anthropic.com>
Claude-Session: https://claude.ai/code/session_01PyQDDPKwUxu1Vg7o8uyr7W
</commit_message>
<xml_diff>
--- a/disciplina-01-estado-governo-mercado/materiais/01_Unidade_1_Introducao_a_Economia_Estado_Governo_Mercado.pptx
+++ b/disciplina-01-estado-governo-mercado/materiais/01_Unidade_1_Introducao_a_Economia_Estado_Governo_Mercado.pptx
@@ -1601,7 +1601,7 @@
           <a:p>
             <a:r>
               <a:rPr lang="en-US" dirty="0"/>
-              <a:t/>
+              <a:t>Olá, turma! Sejam bem-vindos e bem-vindas à Unidade 1 da disciplina Estado, Governo e Mercado. Eu sou o Prof. Dr. Cleiton Franco. Nesta videoaula, vamos construir a base de toda a disciplina: alguns conceitos fundamentais de economia e a diferença entre Estado, governo e mercado. Tenha papel e caneta por perto, porque esses conceitos vão aparecer nos fóruns e nas avaliações.</a:t>
             </a:r>
             <a:endParaRPr lang="en-US" dirty="0"/>
           </a:p>
@@ -1689,7 +1689,7 @@
           <a:p>
             <a:r>
               <a:rPr lang="en-US" dirty="0"/>
-              <a:t/>
+              <a:t>Como o mercado coordena as decisões? Pelos preços. A lei da demanda diz que, quando o preço sobe, a quantidade demandada cai. A lei da oferta diz que, quando o preço sobe, a quantidade ofertada aumenta. O equilíbrio acontece no preço em que a quantidade que as pessoas querem comprar é igual à que as empresas querem vender. Fora do equilíbrio, um preço acima gera sobra, e um preço abaixo gera falta.</a:t>
             </a:r>
             <a:endParaRPr lang="en-US" dirty="0"/>
           </a:p>
@@ -1777,7 +1777,7 @@
           <a:p>
             <a:r>
               <a:rPr lang="en-US" dirty="0"/>
-              <a:t/>
+              <a:t>E quando o governo fixa o preço? Pense numa tarifa de ônibus congelada abaixo do custo por passageiro, sem nenhum subsídio. A empresa tende a reduzir a frota: os ônibus lotam e os intervalos aumentam. É exatamente o excesso de demanda que o modelo prevê. Um preço máximo, ou teto, abaixo do equilíbrio gera falta, filas e perda de qualidade. Um preço mínimo, ou piso, acima do equilíbrio gera sobra. Uma alternativa é o subsídio: o poder público cobre parte do custo e mantém a oferta. Nenhuma dessas escolhas é neutra; cada uma tem custos e beneficiários.</a:t>
             </a:r>
             <a:endParaRPr lang="en-US" dirty="0"/>
           </a:p>
@@ -1865,7 +1865,7 @@
           <a:p>
             <a:r>
               <a:rPr lang="en-US" dirty="0"/>
-              <a:t/>
+              <a:t>Vamos ver esse caso no gráfico. [Apontar para o cruzamento das linhas.] A linha vermelha é a demanda dos passageiros e a verde, a oferta da empresa. Elas se cruzam em 4 reais e 50 centavos, com 100 mil viagens por dia: esse é o equilíbrio. Se a tarifa for congelada em 3 reais, os passageiros querem 130 mil viagens, mas a empresa só oferece 60 mil. Faltam 70 mil viagens por dia, que aparecem como ônibus lotados e filas. As saídas são um subsídio ou uma tarifa que cubra o custo. São dados hipotéticos, para ilustrar o modelo.</a:t>
             </a:r>
             <a:endParaRPr lang="en-US" dirty="0"/>
           </a:p>
@@ -1953,7 +1953,7 @@
           <a:p>
             <a:r>
               <a:rPr lang="en-US" dirty="0"/>
-              <a:t/>
+              <a:t>Agora, a Parte 2: os conceitos básicos da disciplina, Estado, governo e mercado. Parecem óbvios, mas são confundidos com frequência, inclusive no noticiário.</a:t>
             </a:r>
             <a:endParaRPr lang="en-US" dirty="0"/>
           </a:p>
@@ -2041,7 +2041,7 @@
           <a:p>
             <a:r>
               <a:rPr lang="en-US" dirty="0"/>
-              <a:t/>
+              <a:t>O Estado tem três elementos constitutivos. O povo: o conjunto de pessoas vinculadas juridicamente ao Estado, os cidadãos. O território: o espaço físico sobre o qual o Estado exerce o seu poder. E a soberania: o poder supremo dentro do território e a independência em relação a outros Estados. O Estado moderno nasce da centralização do poder político, entre os séculos XV e XVII, quando surgem exércitos, tributos e administração permanentes.</a:t>
             </a:r>
             <a:endParaRPr lang="en-US" dirty="0"/>
           </a:p>
@@ -2129,7 +2129,7 @@
           <a:p>
             <a:r>
               <a:rPr lang="en-US" dirty="0"/>
-              <a:t/>
+              <a:t>Max Weber nos dá uma das definições mais conhecidas: o Estado é a comunidade humana que reivindica, com êxito, o monopólio do uso legítimo da força física em um território. A palavra-chave é legítimo. E por que as pessoas obedecem? Weber identifica três tipos de dominação. A tradicional, baseada no costume, como a do monarca. A carismática, baseada nas qualidades extraordinárias de um líder. E a legal-racional, baseada em normas impessoais, que é a base da burocracia moderna. No Brasil, o concurso público e os princípios do artigo 37 da Constituição, legalidade, impessoalidade, moralidade, publicidade e eficiência, expressam a dominação legal-racional.</a:t>
             </a:r>
             <a:endParaRPr lang="en-US" dirty="0"/>
           </a:p>
@@ -2217,7 +2217,7 @@
           <a:p>
             <a:r>
               <a:rPr lang="en-US" dirty="0"/>
-              <a:t/>
+              <a:t>Vamos separar os conceitos. O Estado é a organização permanente e soberana sobre um território. O governo é o grupo que dirige o Estado num dado momento, e é transitório. O mercado é a coordenação descentralizada da economia, pela troca voluntária e pelos preços. E há a sociedade civil: associações, movimentos e o terceiro setor, que não são Estado nem mercado em sentido estrito. Um teste simples: quando o governo muda depois de uma eleição, o Estado brasileiro continua o mesmo. Mudam os governantes; permanecem as instituições.</a:t>
             </a:r>
             <a:endParaRPr lang="en-US" dirty="0"/>
           </a:p>
@@ -2305,7 +2305,7 @@
           <a:p>
             <a:r>
               <a:rPr lang="en-US" dirty="0"/>
-              <a:t/>
+              <a:t>O governo pode ser analisado por três ângulos. Pela forma: monarquia ou república; na república, o chefe de Estado é eleito e governa por mandato. Pelo sistema: presidencialismo ou parlamentarismo; no presidencialismo, o presidente é, ao mesmo tempo, chefe de Estado e de governo. E pela separação dos poderes: Executivo, Legislativo e Judiciário, porque, como dizia Montesquieu, o poder deve limitar o poder. O Brasil é uma república federativa presidencialista, com União, estados, Distrito Federal e municípios. No município, o Executivo é o prefeito e o Legislativo, a Câmara Municipal.</a:t>
             </a:r>
             <a:endParaRPr lang="en-US" dirty="0"/>
           </a:p>
@@ -2393,7 +2393,7 @@
           <a:p>
             <a:r>
               <a:rPr lang="en-US" dirty="0"/>
-              <a:t/>
+              <a:t>Um ponto importante: o mercado não funciona no vazio. Ele precisa de propriedade definida e contratos cumpridos, de moeda estável, de concorrência, com muitos compradores e vendedores, e de informação sobre preços e qualidade. E quem garante tudo isso? O próprio Estado: a Justiça faz cumprir os contratos, o Banco Central cuida da moeda e os órgãos de defesa da concorrência combatem os abusos. Por isso, Estado e mercado não são simplesmente opostos: um depende do outro.</a:t>
             </a:r>
             <a:endParaRPr lang="en-US" dirty="0"/>
           </a:p>
@@ -2481,7 +2481,7 @@
           <a:p>
             <a:r>
               <a:rPr lang="en-US" dirty="0"/>
-              <a:t/>
+              <a:t>Os bens podem ser classificados por dois critérios. A rivalidade: quando o consumo de uma pessoa reduz o que sobra para as outras. E a exclusão: quando é possível impedir alguém de usar. Bens rivais e excludentes são os bens privados: alimento, roupa, carro. Excludentes, mas não rivais, são os bens de clube, como a TV por assinatura ou a rodovia com pedágio. Rivais, mas não excludentes, são os recursos comuns, como os peixes de um rio. E não rivais e não excludentes são os bens públicos, como a defesa e a iluminação pública. Ninguém pode ser impedido de usar a rua iluminada; por isso o município oferece a iluminação e a financia com a COSIP, a contribuição prevista no artigo 149-A da Constituição.</a:t>
             </a:r>
             <a:endParaRPr lang="en-US" dirty="0"/>
           </a:p>
@@ -2569,7 +2569,7 @@
           <a:p>
             <a:r>
               <a:rPr lang="en-US" dirty="0"/>
-              <a:t/>
+              <a:t>Antes de começar, um lembrete da organização. Esta unidade vai de 9 a 18 de outubro. A leitura principal é o livro de Ricardo Corrêa Coelho, Estado, governo e mercado, na parte dos conceitos básicos, junto com as Unidades 1 e 2 da página de conteúdos. O fórum de apresentação e o fórum temático 1 ficam abertos até 18 de outubro, às 23h55. A videoaula tem duas partes: primeiro, fundamentos de economia; depois, os conceitos de Estado, governo e mercado.</a:t>
             </a:r>
             <a:endParaRPr lang="en-US" dirty="0"/>
           </a:p>
@@ -2657,7 +2657,7 @@
           <a:p>
             <a:r>
               <a:rPr lang="en-US" dirty="0"/>
-              <a:t/>
+              <a:t>Isso nos leva à pergunta central: por que o Estado atua na economia? A teoria econômica responde com as falhas de mercado. Os bens públicos, que o mercado não oferece sozinho. As externalidades, negativas como a poluição, ou positivas como a vacinação e a educação. O poder de mercado, como os monopólios naturais de saneamento e energia. A assimetria de informação, em áreas como saúde, crédito e medicamentos. A instabilidade: desemprego, recessão e inflação. E a desigualdade, quando a distribuição da renda é considerada injusta. Mas atenção: também existem falhas de governo, como a captura por interesses privados, a ineficiência, a corrupção e a rigidez burocrática. O Estado não é uma solução automática.</a:t>
             </a:r>
             <a:endParaRPr lang="en-US" dirty="0"/>
           </a:p>
@@ -2745,7 +2745,7 @@
           <a:p>
             <a:r>
               <a:rPr lang="en-US" dirty="0"/>
-              <a:t/>
+              <a:t>Vamos trazer isso para Mato Grosso. As queimadas são uma externalidade negativa: a fumaça afeta a saúde de quem mora longe do foco, e a resposta pública é fiscalização, multas e brigadas. A energia elétrica é um monopólio natural: não faz sentido ter várias redes de distribuição, então a ANEEL regula tarifas e qualidade. Os medicamentos envolvem assimetria de informação: o paciente não consegue avaliar o remédio, por isso existem o registro e a vigilância sanitária da ANVISA. E a vacinação é uma externalidade positiva: protege também quem não se vacinou, por isso o SUS oferece as vacinas de graça.</a:t>
             </a:r>
             <a:endParaRPr lang="en-US" dirty="0"/>
           </a:p>
@@ -2833,7 +2833,7 @@
           <a:p>
             <a:r>
               <a:rPr lang="en-US" dirty="0"/>
-              <a:t/>
+              <a:t>Richard Musgrave organizou as funções econômicas do Estado em três. A função alocativa: ofertar bens que o mercado não provê de forma adequada, como segurança, saneamento e infraestrutura. A função distributiva: ajustar a distribuição da renda, com tributação progressiva e programas como o Bolsa Família e o BPC. E a função estabilizadora: buscar emprego, preços estáveis e crescimento, por meio das políticas fiscal e monetária.</a:t>
             </a:r>
             <a:endParaRPr lang="en-US" dirty="0"/>
           </a:p>
@@ -2921,7 +2921,7 @@
           <a:p>
             <a:r>
               <a:rPr lang="en-US" dirty="0"/>
-              <a:t/>
+              <a:t>E no município? A função alocativa é a mais presente: UBS, escolas, pavimentação, coleta de lixo e iluminação. A distributiva aparece no IPTU progressivo, na tarifa social de água, no CRAS e na assistência social. A estabilizadora é limitada, porque a política monetária e boa parte da política fiscal são da União; mas o município pode, por exemplo, antecipar obras em anos de crise para gerar empregos. Fica a pergunta para o fórum: que função cumpre a política pública que você escolheu?</a:t>
             </a:r>
             <a:endParaRPr lang="en-US" dirty="0"/>
           </a:p>
@@ -3009,7 +3009,7 @@
           <a:p>
             <a:r>
               <a:rPr lang="en-US" dirty="0"/>
-              <a:t/>
+              <a:t>Este gráfico mostra como um município hipotético distribui a sua despesa por função. [Apontar para as fatias.] Educação, com 27%, e saúde, com 22%, somam quase metade do gasto. Há uma razão para isso: a Constituição exige aplicar ao menos 25% da receita de impostos, incluindo as transferências, em educação, e 15% em saúde. A maior parte do orçamento cumpre a função alocativa; a assistência social, com 5%, é o exemplo típico da função distributiva. Os dados reais do seu município estão no SICONFI, do Tesouro Nacional. Vale a pena conferir.</a:t>
             </a:r>
             <a:endParaRPr lang="en-US" dirty="0"/>
           </a:p>
@@ -3097,7 +3097,7 @@
           <a:p>
             <a:r>
               <a:rPr lang="en-US" dirty="0"/>
-              <a:t/>
+              <a:t>Vamos às atividades da Unidade 1. A disciplina abre no SIGAA em 9 de outubro, com o vídeo de apresentação e esta videoaula. Até 18 de outubro, participe do fórum de apresentação e do fórum temático 1, que pergunta: que falha de mercado uma política pública do seu município procura corrigir? Todas as entregas vão até as 23h55. Na próxima unidade, vamos estudar a dinâmica pendular entre Estado e mercado e a matriz liberal.</a:t>
             </a:r>
             <a:endParaRPr lang="en-US" dirty="0"/>
           </a:p>
@@ -3185,7 +3185,7 @@
           <a:p>
             <a:r>
               <a:rPr lang="en-US" dirty="0"/>
-              <a:t/>
+              <a:t>Para fechar, um quiz com cinco perguntas. Funciona assim: eu leio a pergunta, você pausa o vídeo, escolhe a sua resposta e, no slide seguinte, confere a correção. Vamos lá?</a:t>
             </a:r>
             <a:endParaRPr lang="en-US" dirty="0"/>
           </a:p>
@@ -3273,7 +3273,7 @@
           <a:p>
             <a:r>
               <a:rPr lang="en-US" dirty="0"/>
-              <a:t/>
+              <a:t>Pergunta 1. Qual destes NÃO é um elemento constitutivo do Estado? Letra a: Povo. Letra b: Território. Letra c: Soberania. Letra d: Mercado. Pause o vídeo e escolha a sua resposta.</a:t>
             </a:r>
             <a:endParaRPr lang="en-US" dirty="0"/>
           </a:p>
@@ -3361,7 +3361,7 @@
           <a:p>
             <a:r>
               <a:rPr lang="en-US" dirty="0"/>
-              <a:t/>
+              <a:t>A resposta correta é a letra d: Mercado. Os elementos clássicos do Estado são povo, território e soberania (poder político). O mercado é outra esfera de coordenação social.</a:t>
             </a:r>
             <a:endParaRPr lang="en-US" dirty="0"/>
           </a:p>
@@ -3449,7 +3449,7 @@
           <a:p>
             <a:r>
               <a:rPr lang="en-US" dirty="0"/>
-              <a:t/>
+              <a:t>Pergunta 2. Concursos públicos, leis e impessoalidade na administração expressam, segundo Weber, a dominação: Letra a: Tradicional. Letra b: Carismática. Letra c: Legal-racional. Letra d: Patrimonial. Pause o vídeo e escolha a sua resposta.</a:t>
             </a:r>
             <a:endParaRPr lang="en-US" dirty="0"/>
           </a:p>
@@ -3537,7 +3537,7 @@
           <a:p>
             <a:r>
               <a:rPr lang="en-US" dirty="0"/>
-              <a:t/>
+              <a:t>Começamos pela Parte 1: fundamentos de economia. Por que um curso de gestão pública começa pela economia? Porque toda decisão pública é, no fundo, uma escolha sobre como usar recursos limitados.</a:t>
             </a:r>
             <a:endParaRPr lang="en-US" dirty="0"/>
           </a:p>
@@ -3625,7 +3625,7 @@
           <a:p>
             <a:r>
               <a:rPr lang="en-US" dirty="0"/>
-              <a:t/>
+              <a:t>A resposta correta é a letra c: Legal-racional. A dominação legal-racional baseia-se na obediência a normas impessoais: é a base da burocracia moderna e do art. 37 da Constituição.</a:t>
             </a:r>
             <a:endParaRPr lang="en-US" dirty="0"/>
           </a:p>
@@ -3713,7 +3713,7 @@
           <a:p>
             <a:r>
               <a:rPr lang="en-US" dirty="0"/>
-              <a:t/>
+              <a:t>Pergunta 3. A iluminação das ruas de uma cidade é um exemplo de bem: Letra a: Privado. Letra b: De clube. Letra c: Comum. Letra d: Público. Pause o vídeo e escolha a sua resposta.</a:t>
             </a:r>
             <a:endParaRPr lang="en-US" dirty="0"/>
           </a:p>
@@ -3801,7 +3801,7 @@
           <a:p>
             <a:r>
               <a:rPr lang="en-US" dirty="0"/>
-              <a:t/>
+              <a:t>A resposta correta é a letra d: Público. É não rival (todos usam ao mesmo tempo) e não excludente (ninguém é impedido de usar). Por isso o mercado não a oferece sozinho.</a:t>
             </a:r>
             <a:endParaRPr lang="en-US" dirty="0"/>
           </a:p>
@@ -3889,7 +3889,7 @@
           <a:p>
             <a:r>
               <a:rPr lang="en-US" dirty="0"/>
-              <a:t/>
+              <a:t>Pergunta 4. A fumaça das queimadas que prejudica a saúde de moradores de outras cidades é: Letra a: Uma externalidade negativa. Letra b: Um bem público. Letra c: Assimetria de informação. Letra d: Um monopólio natural. Pause o vídeo e escolha a sua resposta.</a:t>
             </a:r>
             <a:endParaRPr lang="en-US" dirty="0"/>
           </a:p>
@@ -3977,7 +3977,7 @@
           <a:p>
             <a:r>
               <a:rPr lang="en-US" dirty="0"/>
-              <a:t/>
+              <a:t>A resposta correta é a letra a: Uma externalidade negativa. É um custo imposto a terceiros que não aparece no preço de nenhum produto: uma externalidade negativa, que justifica fiscalização e multas.</a:t>
             </a:r>
             <a:endParaRPr lang="en-US" dirty="0"/>
           </a:p>
@@ -4065,7 +4065,7 @@
           <a:p>
             <a:r>
               <a:rPr lang="en-US" dirty="0"/>
-              <a:t/>
+              <a:t>Pergunta 5. IPTU progressivo e tarifa social de água cumprem qual função econômica do Estado? Letra a: Alocativa. Letra b: Distributiva. Letra c: Estabilizadora. Letra d: Fixação de preços. Pause o vídeo e escolha a sua resposta.</a:t>
             </a:r>
             <a:endParaRPr lang="en-US" dirty="0"/>
           </a:p>
@@ -4153,7 +4153,7 @@
           <a:p>
             <a:r>
               <a:rPr lang="en-US" dirty="0"/>
-              <a:t/>
+              <a:t>A resposta correta é a letra b: Distributiva. São instrumentos da função distributiva: cobram mais de quem tem mais e reduzem o custo para as famílias de baixa renda. Com isso, encerramos a Unidade 1. Revise os conceitos, participe dos fóruns e até a próxima videoaula!</a:t>
             </a:r>
             <a:endParaRPr lang="en-US" dirty="0"/>
           </a:p>
@@ -4241,7 +4241,7 @@
           <a:p>
             <a:r>
               <a:rPr lang="en-US" dirty="0"/>
-              <a:t/>
+              <a:t>Economia é a ciência social que estuda como a sociedade emprega recursos escassos para produzir bens e serviços e distribuí-los entre as pessoas. Duas ideias sustentam essa definição. A primeira é a escassez: os recursos são limitados e as necessidades são praticamente ilimitadas, por isso é preciso escolher. A segunda é o custo de oportunidade: o valor da melhor alternativa de que abrimos mão. Se o município constrói uma ponte, talvez deixe de construir uma escola. Guarde esse conceito, porque ele atravessa todo o curso.</a:t>
             </a:r>
             <a:endParaRPr lang="en-US" dirty="0"/>
           </a:p>
@@ -4329,7 +4329,7 @@
           <a:p>
             <a:r>
               <a:rPr lang="en-US" dirty="0"/>
-              <a:t/>
+              <a:t>Vamos a um exemplo da gestão pública. A prefeitura tem 5 milhões de reais para uma única obra e três opções: ampliar a UBS central, pavimentar 3 quilômetros de ruas ou reformar duas escolas. Se escolher a UBS, o custo de oportunidade são as ruas e as escolas que deixarão de ser feitas. A pergunta do gestor é: qual alternativa gera mais benefício para a população com os mesmos recursos? Para responder, ele conta com o diagnóstico das demandas, com indicadores, com audiências públicas e com o Plano Plurianual, o PPA.</a:t>
             </a:r>
             <a:endParaRPr lang="en-US" dirty="0"/>
           </a:p>
@@ -4417,7 +4417,7 @@
           <a:p>
             <a:r>
               <a:rPr lang="en-US" dirty="0"/>
-              <a:t/>
+              <a:t>Este gráfico mostra a mesma ideia de forma visual. [Apontar para a curva.] É a fronteira de possibilidades do orçamento: cada ponto usa todo o dinheiro disponível. Sem reformar nenhuma escola, dá para pavimentar 12 quilômetros. Reformar a primeira escola custa apenas 1 quilômetro de rua; a quarta escola já custa 6 quilômetros. Ou seja, o custo de oportunidade cresce à medida que avançamos numa direção. E um ponto abaixo da curva significa desperdício: daria para fazer mais com o mesmo orçamento. Os números são hipotéticos, só para ilustrar o raciocínio.</a:t>
             </a:r>
             <a:endParaRPr lang="en-US" dirty="0"/>
           </a:p>
@@ -4505,7 +4505,7 @@
           <a:p>
             <a:r>
               <a:rPr lang="en-US" dirty="0"/>
-              <a:t/>
+              <a:t>Toda sociedade precisa responder a três perguntas. O que produzir: hospitais ou estradas, e em que quantidade? Como produzir: com que tecnologia e com que combinação de trabalho, máquinas e recursos naturais? E para quem produzir: como o produto e a renda serão distribuídos? A forma como cada sociedade responde a essas perguntas define o seu sistema econômico, e é aí que entram o Estado e o mercado.</a:t>
             </a:r>
             <a:endParaRPr lang="en-US" dirty="0"/>
           </a:p>
@@ -4593,7 +4593,7 @@
           <a:p>
             <a:r>
               <a:rPr lang="en-US" dirty="0"/>
-              <a:t/>
+              <a:t>Para produzir, a economia usa fatores de produção, e cada um tem a sua remuneração: a terra recebe aluguel; o trabalho, salário; o capital, juros; e a capacidade empresarial, lucro. Esses fatores circulam entre quatro agentes econômicos. As famílias ofertam fatores e consomem. As empresas contratam fatores e produzem. O governo tributa, oferece serviços, regula e redistribui renda. E o setor externo troca bens e capitais com o país. Repare que o governo também é um agente econômico: ele compra, contrata, paga e arrecada.</a:t>
             </a:r>
             <a:endParaRPr lang="en-US" dirty="0"/>
           </a:p>
@@ -4681,7 +4681,7 @@
           <a:p>
             <a:r>
               <a:rPr lang="en-US" dirty="0"/>
-              <a:t/>
+              <a:t>Quem responde às três perguntas? Depende do sistema econômico. Na economia de mercado, as decisões são descentralizadas e coordenadas pelos preços, com propriedade privada. Na economia planificada, um órgão central define as metas de produção, e a propriedade é estatal ou coletiva. Na economia mista, o mercado convive com regulação, empresas públicas e políticas sociais. Hoje, todas as economias são mistas. O que muda de um país para outro, e de uma época para outra, é o grau de presença do Estado. E esse é o grande tema da nossa disciplina.</a:t>
             </a:r>
             <a:endParaRPr lang="en-US" dirty="0"/>
           </a:p>

</xml_diff>

<commit_message>
Encerra cada unidade de Estado, Governo e Mercado com um slide de resumo
Resumo por tópico do sumário ao final de cada unidade, com a fala de
encerramento no roteiro de gravação.

Co-Authored-By: Claude Opus 5.5 <noreply@anthropic.com>
Claude-Session: https://claude.ai/code/session_01PyQDDPKwUxu1Vg7o8uyr7W
</commit_message>
<xml_diff>
--- a/disciplina-01-estado-governo-mercado/materiais/01_Unidade_1_Introducao_a_Economia_Estado_Governo_Mercado.pptx
+++ b/disciplina-01-estado-governo-mercado/materiais/01_Unidade_1_Introducao_a_Economia_Estado_Governo_Mercado.pptx
@@ -43,9 +43,10 @@
     <p:sldId id="291" r:id="rId37"/>
     <p:sldId id="292" r:id="rId38"/>
     <p:sldId id="293" r:id="rId39"/>
+    <p:sldId id="294" r:id="rId40"/>
   </p:sldIdLst>
   <p:notesMasterIdLst>
-    <p:notesMasterId r:id="rId40"/>
+    <p:notesMasterId r:id="rId41"/>
   </p:notesMasterIdLst>
   <p:sldSz cx="9144000" cy="5143500"/>
   <p:notesSz cx="5143500" cy="9144000"/>
@@ -4331,7 +4332,7 @@
           <a:p>
             <a:r>
               <a:rPr lang="en-US" dirty="0"/>
-              <a:t>A resposta correta é a letra b: Distributiva. São instrumentos da função distributiva: cobram mais de quem tem mais e reduzem o custo para as famílias de baixa renda. Com isso, encerramos a Unidade 1. Revise os conceitos, participe dos fóruns e até a próxima videoaula!</a:t>
+              <a:t>A resposta correta é a letra b: Distributiva. São instrumentos da função distributiva: cobram mais de quem tem mais e reduzem o custo para as famílias de baixa renda.</a:t>
             </a:r>
             <a:endParaRPr lang="en-US" dirty="0"/>
           </a:p>
@@ -4355,6 +4356,94 @@
             <a:fld id="{F7021451-1387-4CA6-816F-3879F97B5CBC}" type="slidenum">
               <a:rPr lang="en-US"/>
               <a:t>38</a:t>
+            </a:fld>
+            <a:endParaRPr lang="en-US"/>
+          </a:p>
+        </p:txBody>
+      </p:sp>
+    </p:spTree>
+    <p:extLst>
+      <p:ext uri="{BB962C8B-B14F-4D97-AF65-F5344CB8AC3E}">
+        <p14:creationId xmlns:p14="http://schemas.microsoft.com/office/powerpoint/2010/main" val="1024086991"/>
+      </p:ext>
+    </p:extLst>
+  </p:cSld>
+  <p:clrMapOvr>
+    <a:masterClrMapping/>
+  </p:clrMapOvr>
+</p:notes>
+</file>
+
+<file path=ppt/notesSlides/notesSlide39.xml><?xml version="1.0" encoding="utf-8"?>
+<p:notes xmlns:a="http://schemas.openxmlformats.org/drawingml/2006/main" xmlns:r="http://schemas.openxmlformats.org/officeDocument/2006/relationships" xmlns:p="http://schemas.openxmlformats.org/presentationml/2006/main">
+  <p:cSld>
+    <p:spTree>
+      <p:nvGrpSpPr>
+        <p:cNvPr id="1" name=""/>
+        <p:cNvGrpSpPr/>
+        <p:nvPr/>
+      </p:nvGrpSpPr>
+      <p:grpSpPr>
+        <a:xfrm>
+          <a:off x="0" y="0"/>
+          <a:ext cx="0" cy="0"/>
+          <a:chOff x="0" y="0"/>
+          <a:chExt cx="0" cy="0"/>
+        </a:xfrm>
+      </p:grpSpPr>
+      <p:sp>
+        <p:nvSpPr>
+          <p:cNvPr id="2" name="Slide Image Placeholder 1"/>
+          <p:cNvSpPr>
+            <a:spLocks noGrp="1" noRot="1" noChangeAspect="1"/>
+          </p:cNvSpPr>
+          <p:nvPr>
+            <p:ph type="sldImg"/>
+          </p:nvPr>
+        </p:nvSpPr>
+        <p:spPr/>
+      </p:sp>
+      <p:sp>
+        <p:nvSpPr>
+          <p:cNvPr id="3" name="Notes Placeholder 2"/>
+          <p:cNvSpPr>
+            <a:spLocks noGrp="1"/>
+          </p:cNvSpPr>
+          <p:nvPr>
+            <p:ph type="body" idx="1"/>
+          </p:nvPr>
+        </p:nvSpPr>
+        <p:spPr/>
+        <p:txBody>
+          <a:bodyPr/>
+          <a:lstStyle/>
+          <a:p>
+            <a:r>
+              <a:rPr lang="en-US" dirty="0"/>
+              <a:t>Para fechar a Unidade 1, vamos recapitular. [Apontar para o quadro da esquerda.] No tópico 1, vimos que a economia estuda como a sociedade faz escolhas com recursos escassos, e que toda escolha tem um custo de oportunidade. Toda sociedade precisa responder o que, como e para quem produzir. Conhecemos os fatores de produção e os agentes econômicos, vimos que os preços coordenam o mercado, que todas as economias atuais são mistas, e a diferença entre micro e macroeconomia. [Apontar para o quadro da direita.] No tópico 2, separamos Estado e governo: o Estado, com povo, território e soberania, é permanente; o governo é transitório. Com Weber, entendemos o Estado como o monopólio do uso legítimo da força. Vimos que o mercado depende de instituições garantidas pelo Estado, que as falhas de mercado justificam a ação estatal, mas que o Estado também falha, e conhecemos as três funções de Musgrave: alocativa, distributiva e estabilizadora. Na próxima unidade, estudaremos a dinâmica pendular e a matriz liberal. Revise os conceitos, participe dos fóruns e até a próxima videoaula!</a:t>
+            </a:r>
+            <a:endParaRPr lang="en-US" dirty="0"/>
+          </a:p>
+        </p:txBody>
+      </p:sp>
+      <p:sp>
+        <p:nvSpPr>
+          <p:cNvPr id="4" name="Slide Number Placeholder 3"/>
+          <p:cNvSpPr>
+            <a:spLocks noGrp="1"/>
+          </p:cNvSpPr>
+          <p:nvPr>
+            <p:ph type="sldNum" sz="quarter" idx="10"/>
+          </p:nvPr>
+        </p:nvSpPr>
+        <p:spPr/>
+        <p:txBody>
+          <a:bodyPr/>
+          <a:lstStyle/>
+          <a:p>
+            <a:fld id="{F7021451-1387-4CA6-816F-3879F97B5CBC}" type="slidenum">
+              <a:rPr lang="en-US"/>
+              <a:t>39</a:t>
             </a:fld>
             <a:endParaRPr lang="en-US"/>
           </a:p>
@@ -25065,6 +25154,605 @@
 </p:sld>
 </file>
 
+<file path=ppt/slides/slide39.xml><?xml version="1.0" encoding="utf-8"?>
+<p:sld xmlns:a="http://schemas.openxmlformats.org/drawingml/2006/main" xmlns:r="http://schemas.openxmlformats.org/officeDocument/2006/relationships" xmlns:p="http://schemas.openxmlformats.org/presentationml/2006/main">
+  <p:cSld name="Slide 39">
+    <p:bg>
+      <p:bgPr>
+        <a:blipFill dpi="0" rotWithShape="1">
+          <a:blip r:embed="rId1">
+            <a:lum/>
+          </a:blip>
+          <a:srcRect/>
+          <a:stretch>
+            <a:fillRect/>
+          </a:stretch>
+        </a:blipFill>
+        <a:effectLst/>
+      </p:bgPr>
+    </p:bg>
+    <p:spTree>
+      <p:nvGrpSpPr>
+        <p:cNvPr id="1" name=""/>
+        <p:cNvGrpSpPr/>
+        <p:nvPr/>
+      </p:nvGrpSpPr>
+      <p:grpSpPr>
+        <a:xfrm>
+          <a:off x="0" y="0"/>
+          <a:ext cx="0" cy="0"/>
+          <a:chOff x="0" y="0"/>
+          <a:chExt cx="0" cy="0"/>
+        </a:xfrm>
+      </p:grpSpPr>
+      <p:sp>
+        <p:nvSpPr>
+          <p:cNvPr id="2" name="Text 0"/>
+          <p:cNvSpPr txBox="1"/>
+          <p:nvPr/>
+        </p:nvSpPr>
+        <p:spPr>
+          <a:xfrm>
+            <a:off x="731520" y="256032"/>
+            <a:ext cx="7680960" cy="566928"/>
+          </a:xfrm>
+          <a:prstGeom prst="rect">
+            <a:avLst/>
+          </a:prstGeom>
+          <a:noFill/>
+          <a:ln/>
+        </p:spPr>
+        <p:txBody>
+          <a:bodyPr wrap="square" lIns="0" tIns="0" rIns="0" bIns="0" rtlCol="0" anchor="ctr"/>
+          <a:lstStyle/>
+          <a:p>
+            <a:pPr algn="ctr" indent="0" marL="0">
+              <a:lnSpc>
+                <a:spcPct val="100000"/>
+              </a:lnSpc>
+              <a:buNone/>
+            </a:pPr>
+            <a:r>
+              <a:rPr lang="en-US" sz="2800" b="1" dirty="0">
+                <a:solidFill>
+                  <a:srgbClr val="13294B"/>
+                </a:solidFill>
+                <a:latin typeface="Calibri" pitchFamily="34" charset="0"/>
+                <a:ea typeface="Calibri" pitchFamily="34" charset="-122"/>
+                <a:cs typeface="Calibri" pitchFamily="34" charset="-120"/>
+              </a:rPr>
+              <a:t>Resumo da Unidade 1</a:t>
+            </a:r>
+            <a:endParaRPr lang="en-US" sz="2800" dirty="0"/>
+          </a:p>
+        </p:txBody>
+      </p:sp>
+      <p:sp>
+        <p:nvSpPr>
+          <p:cNvPr id="3" name="Text 1"/>
+          <p:cNvSpPr txBox="1"/>
+          <p:nvPr/>
+        </p:nvSpPr>
+        <p:spPr>
+          <a:xfrm>
+            <a:off x="1005840" y="804672"/>
+            <a:ext cx="7132320" cy="329184"/>
+          </a:xfrm>
+          <a:prstGeom prst="rect">
+            <a:avLst/>
+          </a:prstGeom>
+          <a:noFill/>
+          <a:ln/>
+        </p:spPr>
+        <p:txBody>
+          <a:bodyPr wrap="square" lIns="0" tIns="0" rIns="0" bIns="0" rtlCol="0" anchor="ctr"/>
+          <a:lstStyle/>
+          <a:p>
+            <a:pPr algn="ctr" indent="0" marL="0">
+              <a:lnSpc>
+                <a:spcPct val="100000"/>
+              </a:lnSpc>
+              <a:buNone/>
+            </a:pPr>
+            <a:r>
+              <a:rPr lang="en-US" sz="1400" dirty="0">
+                <a:solidFill>
+                  <a:srgbClr val="5B6770"/>
+                </a:solidFill>
+                <a:latin typeface="Calibri" pitchFamily="34" charset="0"/>
+                <a:ea typeface="Calibri" pitchFamily="34" charset="-122"/>
+                <a:cs typeface="Calibri" pitchFamily="34" charset="-120"/>
+              </a:rPr>
+              <a:t>O que discutimos nesta unidade</a:t>
+            </a:r>
+            <a:endParaRPr lang="en-US" sz="1400" dirty="0"/>
+          </a:p>
+        </p:txBody>
+      </p:sp>
+      <p:sp>
+        <p:nvSpPr>
+          <p:cNvPr id="4" name="Text 2"/>
+          <p:cNvSpPr txBox="1"/>
+          <p:nvPr/>
+        </p:nvSpPr>
+        <p:spPr>
+          <a:xfrm>
+            <a:off x="685800" y="1170432"/>
+            <a:ext cx="3794760" cy="2743200"/>
+          </a:xfrm>
+          <a:prstGeom prst="roundRect">
+            <a:avLst>
+              <a:gd name="adj" fmla="val 2000"/>
+            </a:avLst>
+          </a:prstGeom>
+          <a:solidFill>
+            <a:srgbClr val="FFFFFF"/>
+          </a:solidFill>
+          <a:ln w="12700">
+            <a:solidFill>
+              <a:srgbClr val="DCD5C1"/>
+            </a:solidFill>
+          </a:ln>
+        </p:spPr>
+        <p:txBody>
+          <a:bodyPr wrap="square" lIns="114300" tIns="114300" rIns="114300" bIns="114300" rtlCol="0" anchor="t"/>
+          <a:lstStyle/>
+          <a:p>
+            <a:pPr algn="l" indent="0" marL="0">
+              <a:lnSpc>
+                <a:spcPct val="100000"/>
+              </a:lnSpc>
+              <a:spcAft>
+                <a:spcPts val="200"/>
+              </a:spcAft>
+              <a:buNone/>
+            </a:pPr>
+            <a:r>
+              <a:rPr lang="en-US" sz="1100" b="1" dirty="0">
+                <a:solidFill>
+                  <a:srgbClr val="2A8C85"/>
+                </a:solidFill>
+                <a:latin typeface="Calibri" pitchFamily="34" charset="0"/>
+                <a:ea typeface="Calibri" pitchFamily="34" charset="-122"/>
+                <a:cs typeface="Calibri" pitchFamily="34" charset="-120"/>
+              </a:rPr>
+              <a:t>PARTE 1 · TÓPICO 1</a:t>
+            </a:r>
+            <a:endParaRPr lang="en-US" sz="1100" dirty="0"/>
+          </a:p>
+          <a:p>
+            <a:pPr algn="l" indent="0" marL="0">
+              <a:lnSpc>
+                <a:spcPct val="100000"/>
+              </a:lnSpc>
+              <a:spcAft>
+                <a:spcPts val="400"/>
+              </a:spcAft>
+              <a:buNone/>
+            </a:pPr>
+            <a:r>
+              <a:rPr lang="en-US" sz="1450" b="1" dirty="0">
+                <a:solidFill>
+                  <a:srgbClr val="13294B"/>
+                </a:solidFill>
+                <a:latin typeface="Calibri" pitchFamily="34" charset="0"/>
+                <a:ea typeface="Calibri" pitchFamily="34" charset="-122"/>
+                <a:cs typeface="Calibri" pitchFamily="34" charset="-120"/>
+              </a:rPr>
+              <a:t>Introdução à economia</a:t>
+            </a:r>
+            <a:endParaRPr lang="en-US" sz="1100" dirty="0"/>
+          </a:p>
+          <a:p>
+            <a:pPr algn="l" marL="177800" indent="-177800">
+              <a:lnSpc>
+                <a:spcPct val="100000"/>
+              </a:lnSpc>
+              <a:spcAft>
+                <a:spcPts val="300"/>
+              </a:spcAft>
+              <a:buSzPct val="100000"/>
+              <a:buChar char="•"/>
+            </a:pPr>
+            <a:r>
+              <a:rPr lang="en-US" sz="1200" dirty="0">
+                <a:solidFill>
+                  <a:srgbClr val="1F2A37"/>
+                </a:solidFill>
+                <a:latin typeface="Calibri" pitchFamily="34" charset="0"/>
+                <a:ea typeface="Calibri" pitchFamily="34" charset="-122"/>
+                <a:cs typeface="Calibri" pitchFamily="34" charset="-120"/>
+              </a:rPr>
+              <a:t>Economia estuda escolhas com recursos escassos; toda escolha tem custo de oportunidade.</a:t>
+            </a:r>
+            <a:endParaRPr lang="en-US" sz="1100" dirty="0"/>
+          </a:p>
+          <a:p>
+            <a:pPr algn="l" marL="177800" indent="-177800">
+              <a:lnSpc>
+                <a:spcPct val="100000"/>
+              </a:lnSpc>
+              <a:spcAft>
+                <a:spcPts val="300"/>
+              </a:spcAft>
+              <a:buSzPct val="100000"/>
+              <a:buChar char="•"/>
+            </a:pPr>
+            <a:r>
+              <a:rPr lang="en-US" sz="1200" dirty="0">
+                <a:solidFill>
+                  <a:srgbClr val="1F2A37"/>
+                </a:solidFill>
+                <a:latin typeface="Calibri" pitchFamily="34" charset="0"/>
+                <a:ea typeface="Calibri" pitchFamily="34" charset="-122"/>
+                <a:cs typeface="Calibri" pitchFamily="34" charset="-120"/>
+              </a:rPr>
+              <a:t>Três problemas: o que, como e para quem produzir.</a:t>
+            </a:r>
+            <a:endParaRPr lang="en-US" sz="1100" dirty="0"/>
+          </a:p>
+          <a:p>
+            <a:pPr algn="l" marL="177800" indent="-177800">
+              <a:lnSpc>
+                <a:spcPct val="100000"/>
+              </a:lnSpc>
+              <a:spcAft>
+                <a:spcPts val="300"/>
+              </a:spcAft>
+              <a:buSzPct val="100000"/>
+              <a:buChar char="•"/>
+            </a:pPr>
+            <a:r>
+              <a:rPr lang="en-US" sz="1200" dirty="0">
+                <a:solidFill>
+                  <a:srgbClr val="1F2A37"/>
+                </a:solidFill>
+                <a:latin typeface="Calibri" pitchFamily="34" charset="0"/>
+                <a:ea typeface="Calibri" pitchFamily="34" charset="-122"/>
+                <a:cs typeface="Calibri" pitchFamily="34" charset="-120"/>
+              </a:rPr>
+              <a:t>Fatores (terra, trabalho, capital, capacidade empresarial) e agentes (famílias, empresas, governo, setor externo).</a:t>
+            </a:r>
+            <a:endParaRPr lang="en-US" sz="1100" dirty="0"/>
+          </a:p>
+          <a:p>
+            <a:pPr algn="l" marL="177800" indent="-177800">
+              <a:lnSpc>
+                <a:spcPct val="100000"/>
+              </a:lnSpc>
+              <a:spcAft>
+                <a:spcPts val="300"/>
+              </a:spcAft>
+              <a:buSzPct val="100000"/>
+              <a:buChar char="•"/>
+            </a:pPr>
+            <a:r>
+              <a:rPr lang="en-US" sz="1200" dirty="0">
+                <a:solidFill>
+                  <a:srgbClr val="1F2A37"/>
+                </a:solidFill>
+                <a:latin typeface="Calibri" pitchFamily="34" charset="0"/>
+                <a:ea typeface="Calibri" pitchFamily="34" charset="-122"/>
+                <a:cs typeface="Calibri" pitchFamily="34" charset="-120"/>
+              </a:rPr>
+              <a:t>Os preços coordenam o mercado; todas as economias são mistas.</a:t>
+            </a:r>
+            <a:endParaRPr lang="en-US" sz="1100" dirty="0"/>
+          </a:p>
+          <a:p>
+            <a:pPr algn="l" marL="177800" indent="-177800">
+              <a:lnSpc>
+                <a:spcPct val="100000"/>
+              </a:lnSpc>
+              <a:spcAft>
+                <a:spcPts val="300"/>
+              </a:spcAft>
+              <a:buSzPct val="100000"/>
+              <a:buChar char="•"/>
+            </a:pPr>
+            <a:r>
+              <a:rPr lang="en-US" sz="1200" dirty="0">
+                <a:solidFill>
+                  <a:srgbClr val="1F2A37"/>
+                </a:solidFill>
+                <a:latin typeface="Calibri" pitchFamily="34" charset="0"/>
+                <a:ea typeface="Calibri" pitchFamily="34" charset="-122"/>
+                <a:cs typeface="Calibri" pitchFamily="34" charset="-120"/>
+              </a:rPr>
+              <a:t>Micro estuda unidades individuais; macro, os agregados.</a:t>
+            </a:r>
+            <a:endParaRPr lang="en-US" sz="1100" dirty="0"/>
+          </a:p>
+        </p:txBody>
+      </p:sp>
+      <p:sp>
+        <p:nvSpPr>
+          <p:cNvPr id="5" name="Text 3"/>
+          <p:cNvSpPr txBox="1"/>
+          <p:nvPr/>
+        </p:nvSpPr>
+        <p:spPr>
+          <a:xfrm>
+            <a:off x="4663440" y="1170432"/>
+            <a:ext cx="3794760" cy="2743200"/>
+          </a:xfrm>
+          <a:prstGeom prst="roundRect">
+            <a:avLst>
+              <a:gd name="adj" fmla="val 2000"/>
+            </a:avLst>
+          </a:prstGeom>
+          <a:solidFill>
+            <a:srgbClr val="E6F2F0"/>
+          </a:solidFill>
+          <a:ln/>
+        </p:spPr>
+        <p:txBody>
+          <a:bodyPr wrap="square" lIns="114300" tIns="114300" rIns="114300" bIns="114300" rtlCol="0" anchor="t"/>
+          <a:lstStyle/>
+          <a:p>
+            <a:pPr algn="l" indent="0" marL="0">
+              <a:lnSpc>
+                <a:spcPct val="100000"/>
+              </a:lnSpc>
+              <a:spcAft>
+                <a:spcPts val="200"/>
+              </a:spcAft>
+              <a:buNone/>
+            </a:pPr>
+            <a:r>
+              <a:rPr lang="en-US" sz="1100" b="1" dirty="0">
+                <a:solidFill>
+                  <a:srgbClr val="2A8C85"/>
+                </a:solidFill>
+                <a:latin typeface="Calibri" pitchFamily="34" charset="0"/>
+                <a:ea typeface="Calibri" pitchFamily="34" charset="-122"/>
+                <a:cs typeface="Calibri" pitchFamily="34" charset="-120"/>
+              </a:rPr>
+              <a:t>PARTE 2 · TÓPICO 2</a:t>
+            </a:r>
+            <a:endParaRPr lang="en-US" sz="1100" dirty="0"/>
+          </a:p>
+          <a:p>
+            <a:pPr algn="l" indent="0" marL="0">
+              <a:lnSpc>
+                <a:spcPct val="100000"/>
+              </a:lnSpc>
+              <a:spcAft>
+                <a:spcPts val="400"/>
+              </a:spcAft>
+              <a:buNone/>
+            </a:pPr>
+            <a:r>
+              <a:rPr lang="en-US" sz="1450" b="1" dirty="0">
+                <a:solidFill>
+                  <a:srgbClr val="13294B"/>
+                </a:solidFill>
+                <a:latin typeface="Calibri" pitchFamily="34" charset="0"/>
+                <a:ea typeface="Calibri" pitchFamily="34" charset="-122"/>
+                <a:cs typeface="Calibri" pitchFamily="34" charset="-120"/>
+              </a:rPr>
+              <a:t>Estado, governo e mercado</a:t>
+            </a:r>
+            <a:endParaRPr lang="en-US" sz="1100" dirty="0"/>
+          </a:p>
+          <a:p>
+            <a:pPr algn="l" marL="177800" indent="-177800">
+              <a:lnSpc>
+                <a:spcPct val="100000"/>
+              </a:lnSpc>
+              <a:spcAft>
+                <a:spcPts val="300"/>
+              </a:spcAft>
+              <a:buSzPct val="100000"/>
+              <a:buChar char="•"/>
+            </a:pPr>
+            <a:r>
+              <a:rPr lang="en-US" sz="1200" dirty="0">
+                <a:solidFill>
+                  <a:srgbClr val="1F2A37"/>
+                </a:solidFill>
+                <a:latin typeface="Calibri" pitchFamily="34" charset="0"/>
+                <a:ea typeface="Calibri" pitchFamily="34" charset="-122"/>
+                <a:cs typeface="Calibri" pitchFamily="34" charset="-120"/>
+              </a:rPr>
+              <a:t>Estado (povo, território, soberania) é permanente; governo é transitório.</a:t>
+            </a:r>
+            <a:endParaRPr lang="en-US" sz="1100" dirty="0"/>
+          </a:p>
+          <a:p>
+            <a:pPr algn="l" marL="177800" indent="-177800">
+              <a:lnSpc>
+                <a:spcPct val="100000"/>
+              </a:lnSpc>
+              <a:spcAft>
+                <a:spcPts val="300"/>
+              </a:spcAft>
+              <a:buSzPct val="100000"/>
+              <a:buChar char="•"/>
+            </a:pPr>
+            <a:r>
+              <a:rPr lang="en-US" sz="1200" dirty="0">
+                <a:solidFill>
+                  <a:srgbClr val="1F2A37"/>
+                </a:solidFill>
+                <a:latin typeface="Calibri" pitchFamily="34" charset="0"/>
+                <a:ea typeface="Calibri" pitchFamily="34" charset="-122"/>
+                <a:cs typeface="Calibri" pitchFamily="34" charset="-120"/>
+              </a:rPr>
+              <a:t>Weber: monopólio do uso legítimo da força; dominação legal-racional.</a:t>
+            </a:r>
+            <a:endParaRPr lang="en-US" sz="1100" dirty="0"/>
+          </a:p>
+          <a:p>
+            <a:pPr algn="l" marL="177800" indent="-177800">
+              <a:lnSpc>
+                <a:spcPct val="100000"/>
+              </a:lnSpc>
+              <a:spcAft>
+                <a:spcPts val="300"/>
+              </a:spcAft>
+              <a:buSzPct val="100000"/>
+              <a:buChar char="•"/>
+            </a:pPr>
+            <a:r>
+              <a:rPr lang="en-US" sz="1200" dirty="0">
+                <a:solidFill>
+                  <a:srgbClr val="1F2A37"/>
+                </a:solidFill>
+                <a:latin typeface="Calibri" pitchFamily="34" charset="0"/>
+                <a:ea typeface="Calibri" pitchFamily="34" charset="-122"/>
+                <a:cs typeface="Calibri" pitchFamily="34" charset="-120"/>
+              </a:rPr>
+              <a:t>O mercado depende de instituições garantidas pelo Estado.</a:t>
+            </a:r>
+            <a:endParaRPr lang="en-US" sz="1100" dirty="0"/>
+          </a:p>
+          <a:p>
+            <a:pPr algn="l" marL="177800" indent="-177800">
+              <a:lnSpc>
+                <a:spcPct val="100000"/>
+              </a:lnSpc>
+              <a:spcAft>
+                <a:spcPts val="300"/>
+              </a:spcAft>
+              <a:buSzPct val="100000"/>
+              <a:buChar char="•"/>
+            </a:pPr>
+            <a:r>
+              <a:rPr lang="en-US" sz="1200" dirty="0">
+                <a:solidFill>
+                  <a:srgbClr val="1F2A37"/>
+                </a:solidFill>
+                <a:latin typeface="Calibri" pitchFamily="34" charset="0"/>
+                <a:ea typeface="Calibri" pitchFamily="34" charset="-122"/>
+                <a:cs typeface="Calibri" pitchFamily="34" charset="-120"/>
+              </a:rPr>
+              <a:t>Falhas de mercado justificam a ação do Estado, que também pode falhar.</a:t>
+            </a:r>
+            <a:endParaRPr lang="en-US" sz="1100" dirty="0"/>
+          </a:p>
+          <a:p>
+            <a:pPr algn="l" marL="177800" indent="-177800">
+              <a:lnSpc>
+                <a:spcPct val="100000"/>
+              </a:lnSpc>
+              <a:spcAft>
+                <a:spcPts val="300"/>
+              </a:spcAft>
+              <a:buSzPct val="100000"/>
+              <a:buChar char="•"/>
+            </a:pPr>
+            <a:r>
+              <a:rPr lang="en-US" sz="1200" dirty="0">
+                <a:solidFill>
+                  <a:srgbClr val="1F2A37"/>
+                </a:solidFill>
+                <a:latin typeface="Calibri" pitchFamily="34" charset="0"/>
+                <a:ea typeface="Calibri" pitchFamily="34" charset="-122"/>
+                <a:cs typeface="Calibri" pitchFamily="34" charset="-120"/>
+              </a:rPr>
+              <a:t>Musgrave: funções alocativa, distributiva e estabilizadora.</a:t>
+            </a:r>
+            <a:endParaRPr lang="en-US" sz="1100" dirty="0"/>
+          </a:p>
+        </p:txBody>
+      </p:sp>
+      <p:sp>
+        <p:nvSpPr>
+          <p:cNvPr id="6" name="Text 4"/>
+          <p:cNvSpPr txBox="1"/>
+          <p:nvPr/>
+        </p:nvSpPr>
+        <p:spPr>
+          <a:xfrm>
+            <a:off x="685800" y="3995928"/>
+            <a:ext cx="7772400" cy="484632"/>
+          </a:xfrm>
+          <a:prstGeom prst="roundRect">
+            <a:avLst>
+              <a:gd name="adj" fmla="val 15094"/>
+            </a:avLst>
+          </a:prstGeom>
+          <a:solidFill>
+            <a:srgbClr val="E6F2F0"/>
+          </a:solidFill>
+          <a:ln/>
+        </p:spPr>
+        <p:txBody>
+          <a:bodyPr wrap="square" lIns="127000" tIns="127000" rIns="127000" bIns="127000" rtlCol="0" anchor="ctr"/>
+          <a:lstStyle/>
+          <a:p>
+            <a:pPr algn="ctr" indent="0" marL="0">
+              <a:lnSpc>
+                <a:spcPct val="100000"/>
+              </a:lnSpc>
+              <a:buNone/>
+            </a:pPr>
+            <a:r>
+              <a:rPr lang="en-US" sz="1300" b="1" dirty="0">
+                <a:solidFill>
+                  <a:srgbClr val="13294B"/>
+                </a:solidFill>
+                <a:latin typeface="Calibri" pitchFamily="34" charset="0"/>
+                <a:ea typeface="Calibri" pitchFamily="34" charset="-122"/>
+                <a:cs typeface="Calibri" pitchFamily="34" charset="-120"/>
+              </a:rPr>
+              <a:t>Próxima unidade: a dinâmica pendular entre Estado e mercado e a matriz liberal.</a:t>
+            </a:r>
+            <a:endParaRPr lang="en-US" sz="1300" dirty="0"/>
+          </a:p>
+        </p:txBody>
+      </p:sp>
+      <p:sp>
+        <p:nvSpPr>
+          <p:cNvPr id="7" name="Text 5"/>
+          <p:cNvSpPr txBox="1"/>
+          <p:nvPr/>
+        </p:nvSpPr>
+        <p:spPr>
+          <a:xfrm>
+            <a:off x="4206240" y="36576"/>
+            <a:ext cx="4800600" cy="219456"/>
+          </a:xfrm>
+          <a:prstGeom prst="rect">
+            <a:avLst/>
+          </a:prstGeom>
+          <a:noFill/>
+          <a:ln/>
+        </p:spPr>
+        <p:txBody>
+          <a:bodyPr wrap="square" lIns="0" tIns="0" rIns="0" bIns="0" rtlCol="0" anchor="ctr"/>
+          <a:lstStyle/>
+          <a:p>
+            <a:pPr algn="r" indent="0" marL="0">
+              <a:lnSpc>
+                <a:spcPct val="100000"/>
+              </a:lnSpc>
+              <a:buNone/>
+            </a:pPr>
+            <a:r>
+              <a:rPr lang="en-US" sz="950" dirty="0">
+                <a:solidFill>
+                  <a:srgbClr val="5B6770"/>
+                </a:solidFill>
+                <a:latin typeface="Calibri" pitchFamily="34" charset="0"/>
+                <a:ea typeface="Calibri" pitchFamily="34" charset="-122"/>
+                <a:cs typeface="Calibri" pitchFamily="34" charset="-120"/>
+              </a:rPr>
+              <a:t>Estado, Governo e Mercado · Unidade 1</a:t>
+            </a:r>
+            <a:endParaRPr lang="en-US" sz="950" dirty="0"/>
+          </a:p>
+        </p:txBody>
+      </p:sp>
+    </p:spTree>
+  </p:cSld>
+  <p:clrMapOvr>
+    <a:masterClrMapping/>
+  </p:clrMapOvr>
+</p:sld>
+</file>
+
 <file path=ppt/slides/slide4.xml><?xml version="1.0" encoding="utf-8"?>
 <p:sld xmlns:a="http://schemas.openxmlformats.org/drawingml/2006/main" xmlns:r="http://schemas.openxmlformats.org/officeDocument/2006/relationships" xmlns:p="http://schemas.openxmlformats.org/presentationml/2006/main">
   <p:cSld name="Slide 4">

</xml_diff>